<commit_message>
Update CSV encoding to UTF-8 and refresh empirical output tables/figures
</commit_message>
<xml_diff>
--- a/output/empirical_figures.pptx
+++ b/output/empirical_figures.pptx
@@ -48123,8 +48123,8 @@
           </p:nvSpPr>
           <p:spPr>
             <a:xfrm>
-              <a:off x="492727" y="316514"/>
-              <a:ext cx="8575357" cy="6105268"/>
+              <a:off x="391137" y="316514"/>
+              <a:ext cx="8676947" cy="6105268"/>
             </a:xfrm>
             <a:prstGeom prst="rect">
               <a:avLst/>
@@ -48149,21 +48149,21 @@
           </p:nvSpPr>
           <p:spPr>
             <a:xfrm>
-              <a:off x="492727" y="6421782"/>
-              <a:ext cx="8575357" cy="0"/>
+              <a:off x="391137" y="6421782"/>
+              <a:ext cx="8676947" cy="0"/>
             </a:xfrm>
             <a:custGeom>
               <a:avLst/>
               <a:pathLst>
-                <a:path w="8575357" h="0">
+                <a:path w="8676947" h="0">
                   <a:moveTo>
                     <a:pt x="0" y="0"/>
                   </a:moveTo>
                   <a:lnTo>
-                    <a:pt x="8575357" y="0"/>
-                  </a:lnTo>
-                  <a:lnTo>
-                    <a:pt x="8575357" y="0"/>
+                    <a:pt x="8676947" y="0"/>
+                  </a:lnTo>
+                  <a:lnTo>
+                    <a:pt x="8676947" y="0"/>
                   </a:lnTo>
                 </a:path>
               </a:pathLst>
@@ -48192,21 +48192,21 @@
           </p:nvSpPr>
           <p:spPr>
             <a:xfrm>
-              <a:off x="492727" y="4830937"/>
-              <a:ext cx="8575357" cy="0"/>
+              <a:off x="391137" y="4348936"/>
+              <a:ext cx="8676947" cy="0"/>
             </a:xfrm>
             <a:custGeom>
               <a:avLst/>
               <a:pathLst>
-                <a:path w="8575357" h="0">
+                <a:path w="8676947" h="0">
                   <a:moveTo>
                     <a:pt x="0" y="0"/>
                   </a:moveTo>
                   <a:lnTo>
-                    <a:pt x="8575357" y="0"/>
-                  </a:lnTo>
-                  <a:lnTo>
-                    <a:pt x="8575357" y="0"/>
+                    <a:pt x="8676947" y="0"/>
+                  </a:lnTo>
+                  <a:lnTo>
+                    <a:pt x="8676947" y="0"/>
                   </a:lnTo>
                 </a:path>
               </a:pathLst>
@@ -48235,21 +48235,21 @@
           </p:nvSpPr>
           <p:spPr>
             <a:xfrm>
-              <a:off x="492727" y="3240091"/>
-              <a:ext cx="8575357" cy="0"/>
+              <a:off x="391137" y="2276089"/>
+              <a:ext cx="8676947" cy="0"/>
             </a:xfrm>
             <a:custGeom>
               <a:avLst/>
               <a:pathLst>
-                <a:path w="8575357" h="0">
+                <a:path w="8676947" h="0">
                   <a:moveTo>
                     <a:pt x="0" y="0"/>
                   </a:moveTo>
                   <a:lnTo>
-                    <a:pt x="8575357" y="0"/>
-                  </a:lnTo>
-                  <a:lnTo>
-                    <a:pt x="8575357" y="0"/>
+                    <a:pt x="8676947" y="0"/>
+                  </a:lnTo>
+                  <a:lnTo>
+                    <a:pt x="8676947" y="0"/>
                   </a:lnTo>
                 </a:path>
               </a:pathLst>
@@ -48278,50 +48278,7 @@
           </p:nvSpPr>
           <p:spPr>
             <a:xfrm>
-              <a:off x="492727" y="1649245"/>
-              <a:ext cx="8575357" cy="0"/>
-            </a:xfrm>
-            <a:custGeom>
-              <a:avLst/>
-              <a:pathLst>
-                <a:path w="8575357" h="0">
-                  <a:moveTo>
-                    <a:pt x="0" y="0"/>
-                  </a:moveTo>
-                  <a:lnTo>
-                    <a:pt x="8575357" y="0"/>
-                  </a:lnTo>
-                  <a:lnTo>
-                    <a:pt x="8575357" y="0"/>
-                  </a:lnTo>
-                </a:path>
-              </a:pathLst>
-            </a:custGeom>
-            <a:ln w="8130" cap="flat">
-              <a:solidFill>
-                <a:srgbClr val="E5E5E5">
-                  <a:alpha val="100000"/>
-                </a:srgbClr>
-              </a:solidFill>
-              <a:prstDash val="solid"/>
-              <a:round/>
-            </a:ln>
-          </p:spPr>
-          <p:txBody>
-            <a:bodyPr/>
-            <a:lstStyle/>
-            <a:p/>
-          </p:txBody>
-        </p:sp>
-        <p:sp>
-          <p:nvSpPr>
-            <p:cNvPr id="10" name="pl10"/>
-            <p:cNvSpPr/>
-            <p:nvPr/>
-          </p:nvSpPr>
-          <p:spPr>
-            <a:xfrm>
-              <a:off x="2100606" y="316514"/>
+              <a:off x="2018064" y="316514"/>
               <a:ext cx="0" cy="6105268"/>
             </a:xfrm>
             <a:custGeom>
@@ -48358,13 +48315,13 @@
         </p:sp>
         <p:sp>
           <p:nvSpPr>
-            <p:cNvPr id="11" name="pl11"/>
-            <p:cNvSpPr/>
-            <p:nvPr/>
-          </p:nvSpPr>
-          <p:spPr>
-            <a:xfrm>
-              <a:off x="4780405" y="316514"/>
+            <p:cNvPr id="10" name="pl10"/>
+            <p:cNvSpPr/>
+            <p:nvPr/>
+          </p:nvSpPr>
+          <p:spPr>
+            <a:xfrm>
+              <a:off x="4729610" y="316514"/>
               <a:ext cx="0" cy="6105268"/>
             </a:xfrm>
             <a:custGeom>
@@ -48401,13 +48358,13 @@
         </p:sp>
         <p:sp>
           <p:nvSpPr>
-            <p:cNvPr id="12" name="pl12"/>
-            <p:cNvSpPr/>
-            <p:nvPr/>
-          </p:nvSpPr>
-          <p:spPr>
-            <a:xfrm>
-              <a:off x="7460205" y="316514"/>
+            <p:cNvPr id="11" name="pl11"/>
+            <p:cNvSpPr/>
+            <p:nvPr/>
+          </p:nvSpPr>
+          <p:spPr>
+            <a:xfrm>
+              <a:off x="7441157" y="316514"/>
               <a:ext cx="0" cy="6105268"/>
             </a:xfrm>
             <a:custGeom>
@@ -48444,14 +48401,14 @@
         </p:sp>
         <p:sp>
           <p:nvSpPr>
-            <p:cNvPr id="13" name="rc13"/>
-            <p:cNvSpPr/>
-            <p:nvPr/>
-          </p:nvSpPr>
-          <p:spPr>
-            <a:xfrm>
-              <a:off x="6656265" y="4000197"/>
-              <a:ext cx="1607879" cy="2421585"/>
+            <p:cNvPr id="12" name="rc12"/>
+            <p:cNvSpPr/>
+            <p:nvPr/>
+          </p:nvSpPr>
+          <p:spPr>
+            <a:xfrm>
+              <a:off x="6627693" y="4739046"/>
+              <a:ext cx="1626927" cy="1682736"/>
             </a:xfrm>
             <a:prstGeom prst="rect">
               <a:avLst/>
@@ -48479,14 +48436,14 @@
         </p:sp>
         <p:sp>
           <p:nvSpPr>
-            <p:cNvPr id="14" name="rc14"/>
-            <p:cNvSpPr/>
-            <p:nvPr/>
-          </p:nvSpPr>
-          <p:spPr>
-            <a:xfrm>
-              <a:off x="1296666" y="6393147"/>
-              <a:ext cx="1607879" cy="28635"/>
+            <p:cNvPr id="13" name="rc13"/>
+            <p:cNvSpPr/>
+            <p:nvPr/>
+          </p:nvSpPr>
+          <p:spPr>
+            <a:xfrm>
+              <a:off x="1204600" y="6397323"/>
+              <a:ext cx="1626927" cy="24459"/>
             </a:xfrm>
             <a:prstGeom prst="rect">
               <a:avLst/>
@@ -48514,14 +48471,14 @@
         </p:sp>
         <p:sp>
           <p:nvSpPr>
-            <p:cNvPr id="15" name="rc15"/>
-            <p:cNvSpPr/>
-            <p:nvPr/>
-          </p:nvSpPr>
-          <p:spPr>
-            <a:xfrm>
-              <a:off x="3976466" y="607241"/>
-              <a:ext cx="1607879" cy="5814541"/>
+            <p:cNvPr id="14" name="rc14"/>
+            <p:cNvSpPr/>
+            <p:nvPr/>
+          </p:nvSpPr>
+          <p:spPr>
+            <a:xfrm>
+              <a:off x="3916147" y="607241"/>
+              <a:ext cx="1626927" cy="5814541"/>
             </a:xfrm>
             <a:prstGeom prst="rect">
               <a:avLst/>
@@ -48549,13 +48506,13 @@
         </p:sp>
         <p:sp>
           <p:nvSpPr>
-            <p:cNvPr id="16" name="tx16"/>
-            <p:cNvSpPr/>
-            <p:nvPr/>
-          </p:nvSpPr>
-          <p:spPr>
-            <a:xfrm>
-              <a:off x="7223192" y="3845069"/>
+            <p:cNvPr id="15" name="tx15"/>
+            <p:cNvSpPr/>
+            <p:nvPr/>
+          </p:nvSpPr>
+          <p:spPr>
+            <a:xfrm>
+              <a:off x="7204144" y="4583918"/>
               <a:ext cx="474024" cy="103418"/>
             </a:xfrm>
             <a:prstGeom prst="rect">
@@ -48585,20 +48542,20 @@
                   <a:latin typeface="YaHei"/>
                   <a:cs typeface="YaHei"/>
                 </a:rPr>
-                <a:t>0.761 s</a:t>
+                <a:t>0.812 s</a:t>
               </a:r>
             </a:p>
           </p:txBody>
         </p:sp>
         <p:sp>
           <p:nvSpPr>
-            <p:cNvPr id="17" name="tx17"/>
-            <p:cNvSpPr/>
-            <p:nvPr/>
-          </p:nvSpPr>
-          <p:spPr>
-            <a:xfrm>
-              <a:off x="1863594" y="6238019"/>
+            <p:cNvPr id="16" name="tx16"/>
+            <p:cNvSpPr/>
+            <p:nvPr/>
+          </p:nvSpPr>
+          <p:spPr>
+            <a:xfrm>
+              <a:off x="1781052" y="6242195"/>
               <a:ext cx="474024" cy="103418"/>
             </a:xfrm>
             <a:prstGeom prst="rect">
@@ -48628,20 +48585,20 @@
                   <a:latin typeface="YaHei"/>
                   <a:cs typeface="YaHei"/>
                 </a:rPr>
-                <a:t>0.009 s</a:t>
+                <a:t>0.012 s</a:t>
               </a:r>
             </a:p>
           </p:txBody>
         </p:sp>
         <p:sp>
           <p:nvSpPr>
-            <p:cNvPr id="18" name="tx18"/>
-            <p:cNvSpPr/>
-            <p:nvPr/>
-          </p:nvSpPr>
-          <p:spPr>
-            <a:xfrm>
-              <a:off x="4543393" y="452113"/>
+            <p:cNvPr id="17" name="tx17"/>
+            <p:cNvSpPr/>
+            <p:nvPr/>
+          </p:nvSpPr>
+          <p:spPr>
+            <a:xfrm>
+              <a:off x="4492598" y="452113"/>
               <a:ext cx="474024" cy="103418"/>
             </a:xfrm>
             <a:prstGeom prst="rect">
@@ -48671,20 +48628,20 @@
                   <a:latin typeface="YaHei"/>
                   <a:cs typeface="YaHei"/>
                 </a:rPr>
-                <a:t>1.827 s</a:t>
+                <a:t>2.805 s</a:t>
               </a:r>
             </a:p>
           </p:txBody>
         </p:sp>
         <p:sp>
           <p:nvSpPr>
-            <p:cNvPr id="19" name="pl19"/>
-            <p:cNvSpPr/>
-            <p:nvPr/>
-          </p:nvSpPr>
-          <p:spPr>
-            <a:xfrm>
-              <a:off x="492727" y="316514"/>
+            <p:cNvPr id="18" name="pl18"/>
+            <p:cNvSpPr/>
+            <p:nvPr/>
+          </p:nvSpPr>
+          <p:spPr>
+            <a:xfrm>
+              <a:off x="391137" y="316514"/>
               <a:ext cx="0" cy="6105268"/>
             </a:xfrm>
             <a:custGeom>
@@ -48718,14 +48675,14 @@
         </p:sp>
         <p:sp>
           <p:nvSpPr>
-            <p:cNvPr id="20" name="tx20"/>
+            <p:cNvPr id="19" name="tx19"/>
             <p:cNvSpPr/>
             <p:nvPr/>
           </p:nvSpPr>
           <p:spPr>
             <a:xfrm>
               <a:off x="255056" y="6378166"/>
-              <a:ext cx="169346" cy="87233"/>
+              <a:ext cx="67757" cy="87233"/>
             </a:xfrm>
             <a:prstGeom prst="rect">
               <a:avLst/>
@@ -48754,21 +48711,21 @@
                   <a:latin typeface="YaHei"/>
                   <a:cs typeface="YaHei"/>
                 </a:rPr>
-                <a:t>0.0</a:t>
+                <a:t>0</a:t>
               </a:r>
             </a:p>
           </p:txBody>
         </p:sp>
         <p:sp>
           <p:nvSpPr>
-            <p:cNvPr id="21" name="tx21"/>
-            <p:cNvSpPr/>
-            <p:nvPr/>
-          </p:nvSpPr>
-          <p:spPr>
-            <a:xfrm>
-              <a:off x="255056" y="4787320"/>
-              <a:ext cx="169346" cy="87233"/>
+            <p:cNvPr id="20" name="tx20"/>
+            <p:cNvSpPr/>
+            <p:nvPr/>
+          </p:nvSpPr>
+          <p:spPr>
+            <a:xfrm>
+              <a:off x="255056" y="4305319"/>
+              <a:ext cx="67757" cy="87233"/>
             </a:xfrm>
             <a:prstGeom prst="rect">
               <a:avLst/>
@@ -48797,21 +48754,21 @@
                   <a:latin typeface="YaHei"/>
                   <a:cs typeface="YaHei"/>
                 </a:rPr>
-                <a:t>0.5</a:t>
+                <a:t>1</a:t>
               </a:r>
             </a:p>
           </p:txBody>
         </p:sp>
         <p:sp>
           <p:nvSpPr>
-            <p:cNvPr id="22" name="tx22"/>
-            <p:cNvSpPr/>
-            <p:nvPr/>
-          </p:nvSpPr>
-          <p:spPr>
-            <a:xfrm>
-              <a:off x="255056" y="3196474"/>
-              <a:ext cx="169346" cy="87233"/>
+            <p:cNvPr id="21" name="tx21"/>
+            <p:cNvSpPr/>
+            <p:nvPr/>
+          </p:nvSpPr>
+          <p:spPr>
+            <a:xfrm>
+              <a:off x="255056" y="2232473"/>
+              <a:ext cx="67757" cy="87233"/>
             </a:xfrm>
             <a:prstGeom prst="rect">
               <a:avLst/>
@@ -48840,63 +48797,20 @@
                   <a:latin typeface="YaHei"/>
                   <a:cs typeface="YaHei"/>
                 </a:rPr>
-                <a:t>1.0</a:t>
+                <a:t>2</a:t>
               </a:r>
             </a:p>
           </p:txBody>
         </p:sp>
         <p:sp>
           <p:nvSpPr>
-            <p:cNvPr id="23" name="tx23"/>
-            <p:cNvSpPr/>
-            <p:nvPr/>
-          </p:nvSpPr>
-          <p:spPr>
-            <a:xfrm>
-              <a:off x="255056" y="1605628"/>
-              <a:ext cx="169346" cy="87233"/>
-            </a:xfrm>
-            <a:prstGeom prst="rect">
-              <a:avLst/>
-            </a:prstGeom>
-            <a:noFill/>
-          </p:spPr>
-          <p:txBody>
-            <a:bodyPr lIns="0" rIns="0" tIns="0" bIns="0" anchorCtr="1" anchor="ctr" wrap="none"/>
-            <a:lstStyle/>
-            <a:p>
-              <a:pPr algn="l" marL="0" marR="0" indent="0">
-                <a:spcBef>
-                  <a:spcPts val="0"/>
-                </a:spcBef>
-                <a:spcAft>
-                  <a:spcPts val="0"/>
-                </a:spcAft>
-              </a:pPr>
-              <a:r>
-                <a:rPr sz="960" i="0" b="0">
-                  <a:solidFill>
-                    <a:srgbClr val="444444">
-                      <a:alpha val="100000"/>
-                    </a:srgbClr>
-                  </a:solidFill>
-                  <a:latin typeface="YaHei"/>
-                  <a:cs typeface="YaHei"/>
-                </a:rPr>
-                <a:t>1.5</a:t>
-              </a:r>
-            </a:p>
-          </p:txBody>
-        </p:sp>
-        <p:sp>
-          <p:nvSpPr>
-            <p:cNvPr id="24" name="pl24"/>
-            <p:cNvSpPr/>
-            <p:nvPr/>
-          </p:nvSpPr>
-          <p:spPr>
-            <a:xfrm>
-              <a:off x="454769" y="6421782"/>
+            <p:cNvPr id="22" name="pl22"/>
+            <p:cNvSpPr/>
+            <p:nvPr/>
+          </p:nvSpPr>
+          <p:spPr>
+            <a:xfrm>
+              <a:off x="353179" y="6421782"/>
               <a:ext cx="37957" cy="0"/>
             </a:xfrm>
             <a:custGeom>
@@ -48930,13 +48844,13 @@
         </p:sp>
         <p:sp>
           <p:nvSpPr>
-            <p:cNvPr id="25" name="pl25"/>
-            <p:cNvSpPr/>
-            <p:nvPr/>
-          </p:nvSpPr>
-          <p:spPr>
-            <a:xfrm>
-              <a:off x="454769" y="4830937"/>
+            <p:cNvPr id="23" name="pl23"/>
+            <p:cNvSpPr/>
+            <p:nvPr/>
+          </p:nvSpPr>
+          <p:spPr>
+            <a:xfrm>
+              <a:off x="353179" y="4348936"/>
               <a:ext cx="37957" cy="0"/>
             </a:xfrm>
             <a:custGeom>
@@ -48970,13 +48884,13 @@
         </p:sp>
         <p:sp>
           <p:nvSpPr>
-            <p:cNvPr id="26" name="pl26"/>
-            <p:cNvSpPr/>
-            <p:nvPr/>
-          </p:nvSpPr>
-          <p:spPr>
-            <a:xfrm>
-              <a:off x="454769" y="3240091"/>
+            <p:cNvPr id="24" name="pl24"/>
+            <p:cNvSpPr/>
+            <p:nvPr/>
+          </p:nvSpPr>
+          <p:spPr>
+            <a:xfrm>
+              <a:off x="353179" y="2276089"/>
               <a:ext cx="37957" cy="0"/>
             </a:xfrm>
             <a:custGeom>
@@ -49010,64 +48924,24 @@
         </p:sp>
         <p:sp>
           <p:nvSpPr>
-            <p:cNvPr id="27" name="pl27"/>
-            <p:cNvSpPr/>
-            <p:nvPr/>
-          </p:nvSpPr>
-          <p:spPr>
-            <a:xfrm>
-              <a:off x="454769" y="1649245"/>
-              <a:ext cx="37957" cy="0"/>
+            <p:cNvPr id="25" name="pl25"/>
+            <p:cNvSpPr/>
+            <p:nvPr/>
+          </p:nvSpPr>
+          <p:spPr>
+            <a:xfrm>
+              <a:off x="391137" y="6421782"/>
+              <a:ext cx="8676947" cy="0"/>
             </a:xfrm>
             <a:custGeom>
               <a:avLst/>
               <a:pathLst>
-                <a:path w="37957" h="0">
+                <a:path w="8676947" h="0">
                   <a:moveTo>
                     <a:pt x="0" y="0"/>
                   </a:moveTo>
                   <a:lnTo>
-                    <a:pt x="37957" y="0"/>
-                  </a:lnTo>
-                </a:path>
-              </a:pathLst>
-            </a:custGeom>
-            <a:ln w="14782" cap="flat">
-              <a:solidFill>
-                <a:srgbClr val="333333">
-                  <a:alpha val="100000"/>
-                </a:srgbClr>
-              </a:solidFill>
-              <a:prstDash val="solid"/>
-              <a:round/>
-            </a:ln>
-          </p:spPr>
-          <p:txBody>
-            <a:bodyPr/>
-            <a:lstStyle/>
-            <a:p/>
-          </p:txBody>
-        </p:sp>
-        <p:sp>
-          <p:nvSpPr>
-            <p:cNvPr id="28" name="pl28"/>
-            <p:cNvSpPr/>
-            <p:nvPr/>
-          </p:nvSpPr>
-          <p:spPr>
-            <a:xfrm>
-              <a:off x="492727" y="6421782"/>
-              <a:ext cx="8575357" cy="0"/>
-            </a:xfrm>
-            <a:custGeom>
-              <a:avLst/>
-              <a:pathLst>
-                <a:path w="8575357" h="0">
-                  <a:moveTo>
-                    <a:pt x="0" y="0"/>
-                  </a:moveTo>
-                  <a:lnTo>
-                    <a:pt x="8575357" y="0"/>
+                    <a:pt x="8676947" y="0"/>
                   </a:lnTo>
                 </a:path>
               </a:pathLst>
@@ -49090,13 +48964,13 @@
         </p:sp>
         <p:sp>
           <p:nvSpPr>
-            <p:cNvPr id="29" name="pl29"/>
-            <p:cNvSpPr/>
-            <p:nvPr/>
-          </p:nvSpPr>
-          <p:spPr>
-            <a:xfrm>
-              <a:off x="2100606" y="6421782"/>
+            <p:cNvPr id="26" name="pl26"/>
+            <p:cNvSpPr/>
+            <p:nvPr/>
+          </p:nvSpPr>
+          <p:spPr>
+            <a:xfrm>
+              <a:off x="2018064" y="6421782"/>
               <a:ext cx="0" cy="37957"/>
             </a:xfrm>
             <a:custGeom>
@@ -49130,13 +49004,13 @@
         </p:sp>
         <p:sp>
           <p:nvSpPr>
-            <p:cNvPr id="30" name="pl30"/>
-            <p:cNvSpPr/>
-            <p:nvPr/>
-          </p:nvSpPr>
-          <p:spPr>
-            <a:xfrm>
-              <a:off x="4780405" y="6421782"/>
+            <p:cNvPr id="27" name="pl27"/>
+            <p:cNvSpPr/>
+            <p:nvPr/>
+          </p:nvSpPr>
+          <p:spPr>
+            <a:xfrm>
+              <a:off x="4729610" y="6421782"/>
               <a:ext cx="0" cy="37957"/>
             </a:xfrm>
             <a:custGeom>
@@ -49170,13 +49044,13 @@
         </p:sp>
         <p:sp>
           <p:nvSpPr>
-            <p:cNvPr id="31" name="pl31"/>
-            <p:cNvSpPr/>
-            <p:nvPr/>
-          </p:nvSpPr>
-          <p:spPr>
-            <a:xfrm>
-              <a:off x="7460205" y="6421782"/>
+            <p:cNvPr id="28" name="pl28"/>
+            <p:cNvSpPr/>
+            <p:nvPr/>
+          </p:nvSpPr>
+          <p:spPr>
+            <a:xfrm>
+              <a:off x="7441157" y="6421782"/>
               <a:ext cx="0" cy="37957"/>
             </a:xfrm>
             <a:custGeom>
@@ -49210,13 +49084,13 @@
         </p:sp>
         <p:sp>
           <p:nvSpPr>
-            <p:cNvPr id="32" name="tx32"/>
-            <p:cNvSpPr/>
-            <p:nvPr/>
-          </p:nvSpPr>
-          <p:spPr>
-            <a:xfrm>
-              <a:off x="1753728" y="6490106"/>
+            <p:cNvPr id="29" name="tx29"/>
+            <p:cNvSpPr/>
+            <p:nvPr/>
+          </p:nvSpPr>
+          <p:spPr>
+            <a:xfrm>
+              <a:off x="1671187" y="6490106"/>
               <a:ext cx="693755" cy="87233"/>
             </a:xfrm>
             <a:prstGeom prst="rect">
@@ -49253,13 +49127,13 @@
         </p:sp>
         <p:sp>
           <p:nvSpPr>
-            <p:cNvPr id="33" name="tx33"/>
-            <p:cNvSpPr/>
-            <p:nvPr/>
-          </p:nvSpPr>
-          <p:spPr>
-            <a:xfrm>
-              <a:off x="4430236" y="6490106"/>
+            <p:cNvPr id="30" name="tx30"/>
+            <p:cNvSpPr/>
+            <p:nvPr/>
+          </p:nvSpPr>
+          <p:spPr>
+            <a:xfrm>
+              <a:off x="4379441" y="6490106"/>
               <a:ext cx="700338" cy="87233"/>
             </a:xfrm>
             <a:prstGeom prst="rect">
@@ -49296,13 +49170,13 @@
         </p:sp>
         <p:sp>
           <p:nvSpPr>
-            <p:cNvPr id="34" name="tx34"/>
-            <p:cNvSpPr/>
-            <p:nvPr/>
-          </p:nvSpPr>
-          <p:spPr>
-            <a:xfrm>
-              <a:off x="7247012" y="6490106"/>
+            <p:cNvPr id="31" name="tx31"/>
+            <p:cNvSpPr/>
+            <p:nvPr/>
+          </p:nvSpPr>
+          <p:spPr>
+            <a:xfrm>
+              <a:off x="7227964" y="6490106"/>
               <a:ext cx="426384" cy="87233"/>
             </a:xfrm>
             <a:prstGeom prst="rect">
@@ -49339,13 +49213,13 @@
         </p:sp>
         <p:sp>
           <p:nvSpPr>
-            <p:cNvPr id="35" name="tx35"/>
-            <p:cNvSpPr/>
-            <p:nvPr/>
-          </p:nvSpPr>
-          <p:spPr>
-            <a:xfrm>
-              <a:off x="4666105" y="6640901"/>
+            <p:cNvPr id="32" name="tx32"/>
+            <p:cNvSpPr/>
+            <p:nvPr/>
+          </p:nvSpPr>
+          <p:spPr>
+            <a:xfrm>
+              <a:off x="4615310" y="6640901"/>
               <a:ext cx="228600" cy="109179"/>
             </a:xfrm>
             <a:prstGeom prst="rect">
@@ -49382,7 +49256,7 @@
         </p:sp>
         <p:sp>
           <p:nvSpPr>
-            <p:cNvPr id="36" name="tx36"/>
+            <p:cNvPr id="33" name="tx33"/>
             <p:cNvSpPr/>
             <p:nvPr/>
           </p:nvSpPr>
@@ -49425,13 +49299,13 @@
         </p:sp>
         <p:sp>
           <p:nvSpPr>
-            <p:cNvPr id="37" name="tx37"/>
-            <p:cNvSpPr/>
-            <p:nvPr/>
-          </p:nvSpPr>
-          <p:spPr>
-            <a:xfrm>
-              <a:off x="492727" y="75915"/>
+            <p:cNvPr id="34" name="tx34"/>
+            <p:cNvSpPr/>
+            <p:nvPr/>
+          </p:nvSpPr>
+          <p:spPr>
+            <a:xfrm>
+              <a:off x="391137" y="75915"/>
               <a:ext cx="1466514" cy="127284"/>
             </a:xfrm>
             <a:prstGeom prst="rect">

</xml_diff>